<commit_message>
New slides added to original
</commit_message>
<xml_diff>
--- a/Campus_Form_Assistant.pptx
+++ b/Campus_Form_Assistant.pptx
@@ -11,6 +11,7 @@
     <p:sldId id="259" r:id="rId10"/>
     <p:sldId id="260" r:id="rId11"/>
     <p:sldId id="261" r:id="rId12"/>
+    <p:sldId id="262" r:id="rId13"/>
   </p:sldIdLst>
   <p:sldSz cx="12191695" cy="6858000" type="screen4x3"/>
   <p:notesSz cx="6858000" cy="9144000"/>
@@ -5976,6 +5977,878 @@
 </file>
 
 <file path=ppt/slides/slide6.xml><?xml version="1.0" encoding="utf-8"?>
+<p:sld xmlns:a="http://schemas.openxmlformats.org/drawingml/2006/main" xmlns:p="http://schemas.openxmlformats.org/presentationml/2006/main" xmlns:r="http://schemas.openxmlformats.org/officeDocument/2006/relationships">
+  <p:cSld>
+    <p:spTree>
+      <p:nvGrpSpPr>
+        <p:cNvPr id="1" name=""/>
+        <p:cNvGrpSpPr/>
+        <p:nvPr/>
+      </p:nvGrpSpPr>
+      <p:grpSpPr/>
+      <p:sp>
+        <p:nvSpPr>
+          <p:cNvPr id="2" name="Rectangle 1"/>
+          <p:cNvSpPr/>
+          <p:nvPr/>
+        </p:nvSpPr>
+        <p:spPr>
+          <a:xfrm>
+            <a:off x="0" y="0"/>
+            <a:ext cx="12191695" cy="6858000"/>
+          </a:xfrm>
+          <a:prstGeom prst="rect">
+            <a:avLst/>
+          </a:prstGeom>
+          <a:solidFill>
+            <a:srgbClr val="0F172A"/>
+          </a:solidFill>
+          <a:ln>
+            <a:noFill/>
+          </a:ln>
+          <a:effectLst/>
+        </p:spPr>
+        <p:style>
+          <a:lnRef idx="1">
+            <a:schemeClr val="accent1"/>
+          </a:lnRef>
+          <a:fillRef idx="3">
+            <a:schemeClr val="accent1"/>
+          </a:fillRef>
+          <a:effectRef idx="2">
+            <a:schemeClr val="accent1"/>
+          </a:effectRef>
+          <a:fontRef idx="minor">
+            <a:schemeClr val="lt1"/>
+          </a:fontRef>
+        </p:style>
+        <p:txBody>
+          <a:bodyPr rtlCol="0" anchor="ctr"/>
+          <a:lstStyle/>
+          <a:p>
+            <a:pPr algn="ctr"/>
+          </a:p>
+        </p:txBody>
+      </p:sp>
+      <p:sp>
+        <p:nvSpPr>
+          <p:cNvPr id="3" name="Rectangle 2"/>
+          <p:cNvSpPr/>
+          <p:nvPr/>
+        </p:nvSpPr>
+        <p:spPr>
+          <a:xfrm>
+            <a:off x="0" y="0"/>
+            <a:ext cx="164592" cy="6858000"/>
+          </a:xfrm>
+          <a:prstGeom prst="rect">
+            <a:avLst/>
+          </a:prstGeom>
+          <a:solidFill>
+            <a:srgbClr val="6366F1"/>
+          </a:solidFill>
+          <a:ln>
+            <a:noFill/>
+          </a:ln>
+          <a:effectLst/>
+        </p:spPr>
+        <p:style>
+          <a:lnRef idx="1">
+            <a:schemeClr val="accent1"/>
+          </a:lnRef>
+          <a:fillRef idx="3">
+            <a:schemeClr val="accent1"/>
+          </a:fillRef>
+          <a:effectRef idx="2">
+            <a:schemeClr val="accent1"/>
+          </a:effectRef>
+          <a:fontRef idx="minor">
+            <a:schemeClr val="lt1"/>
+          </a:fontRef>
+        </p:style>
+        <p:txBody>
+          <a:bodyPr rtlCol="0" anchor="ctr"/>
+          <a:lstStyle/>
+          <a:p>
+            <a:pPr algn="ctr"/>
+          </a:p>
+        </p:txBody>
+      </p:sp>
+      <p:sp>
+        <p:nvSpPr>
+          <p:cNvPr id="4" name="TextBox 3"/>
+          <p:cNvSpPr txBox="1"/>
+          <p:nvPr/>
+        </p:nvSpPr>
+        <p:spPr>
+          <a:xfrm>
+            <a:off x="822960" y="457200"/>
+            <a:ext cx="10515600" cy="914400"/>
+          </a:xfrm>
+          <a:prstGeom prst="rect">
+            <a:avLst/>
+          </a:prstGeom>
+          <a:noFill/>
+        </p:spPr>
+        <p:txBody>
+          <a:bodyPr wrap="square" anchor="t">
+            <a:spAutoFit/>
+          </a:bodyPr>
+          <a:lstStyle/>
+          <a:p>
+            <a:pPr algn="l">
+              <a:spcAft>
+                <a:spcPts val="1000"/>
+              </a:spcAft>
+            </a:pPr>
+            <a:r>
+              <a:rPr sz="3600" b="1">
+                <a:solidFill>
+                  <a:srgbClr val="FFFFFF"/>
+                </a:solidFill>
+                <a:latin typeface="Segoe UI"/>
+              </a:rPr>
+              <a:t>Proposed AWS Architecture</a:t>
+            </a:r>
+          </a:p>
+          <a:p>
+            <a:pPr algn="l">
+              <a:spcAft>
+                <a:spcPts val="1000"/>
+              </a:spcAft>
+            </a:pPr>
+            <a:r>
+              <a:rPr sz="2000" b="0">
+                <a:solidFill>
+                  <a:srgbClr val="818CF8"/>
+                </a:solidFill>
+                <a:latin typeface="Segoe UI"/>
+              </a:rPr>
+              <a:t>Deployment plan — mapping each component to an AWS service</a:t>
+            </a:r>
+          </a:p>
+        </p:txBody>
+      </p:sp>
+      <p:sp>
+        <p:nvSpPr>
+          <p:cNvPr id="5" name="Rounded Rectangle 4"/>
+          <p:cNvSpPr/>
+          <p:nvPr/>
+        </p:nvSpPr>
+        <p:spPr>
+          <a:xfrm>
+            <a:off x="822960" y="1691640"/>
+            <a:ext cx="5166360" cy="1371600"/>
+          </a:xfrm>
+          <a:prstGeom prst="roundRect">
+            <a:avLst>
+              <a:gd name="adj" fmla="val 6000"/>
+            </a:avLst>
+          </a:prstGeom>
+          <a:solidFill>
+            <a:srgbClr val="1E293B"/>
+          </a:solidFill>
+          <a:ln w="12700">
+            <a:solidFill>
+              <a:srgbClr val="334155"/>
+            </a:solidFill>
+          </a:ln>
+          <a:effectLst/>
+        </p:spPr>
+        <p:style>
+          <a:lnRef idx="1">
+            <a:schemeClr val="accent1"/>
+          </a:lnRef>
+          <a:fillRef idx="3">
+            <a:schemeClr val="accent1"/>
+          </a:fillRef>
+          <a:effectRef idx="2">
+            <a:schemeClr val="accent1"/>
+          </a:effectRef>
+          <a:fontRef idx="minor">
+            <a:schemeClr val="lt1"/>
+          </a:fontRef>
+        </p:style>
+        <p:txBody>
+          <a:bodyPr rtlCol="0" anchor="ctr"/>
+          <a:lstStyle/>
+          <a:p>
+            <a:pPr algn="ctr"/>
+          </a:p>
+        </p:txBody>
+      </p:sp>
+      <p:sp>
+        <p:nvSpPr>
+          <p:cNvPr id="6" name="TextBox 5"/>
+          <p:cNvSpPr txBox="1"/>
+          <p:nvPr/>
+        </p:nvSpPr>
+        <p:spPr>
+          <a:xfrm>
+            <a:off x="1097280" y="1874520"/>
+            <a:ext cx="4617720" cy="1005840"/>
+          </a:xfrm>
+          <a:prstGeom prst="rect">
+            <a:avLst/>
+          </a:prstGeom>
+          <a:noFill/>
+        </p:spPr>
+        <p:txBody>
+          <a:bodyPr wrap="square" anchor="t">
+            <a:spAutoFit/>
+          </a:bodyPr>
+          <a:lstStyle/>
+          <a:p>
+            <a:pPr>
+              <a:spcAft>
+                <a:spcPts val="400"/>
+              </a:spcAft>
+            </a:pPr>
+            <a:r>
+              <a:rPr sz="1700" b="1">
+                <a:solidFill>
+                  <a:srgbClr val="818CF8"/>
+                </a:solidFill>
+                <a:latin typeface="Segoe UI"/>
+              </a:rPr>
+              <a:t>Amazon Bedrock   </a:t>
+            </a:r>
+            <a:r>
+              <a:rPr sz="1400" i="1">
+                <a:solidFill>
+                  <a:srgbClr val="94A3B8"/>
+                </a:solidFill>
+                <a:latin typeface="Segoe UI"/>
+              </a:rPr>
+              <a:t>· Conversational phrasing</a:t>
+            </a:r>
+          </a:p>
+          <a:p>
+            <a:pPr algn="l">
+              <a:spcAft>
+                <a:spcPts val="0"/>
+              </a:spcAft>
+            </a:pPr>
+            <a:r>
+              <a:rPr sz="1300" b="0">
+                <a:solidFill>
+                  <a:srgbClr val="E2E8F0"/>
+                </a:solidFill>
+                <a:latin typeface="Segoe UI"/>
+              </a:rPr>
+              <a:t>Drop-in for the LLM layer already isolated in the agent — managed, no API keys to ship.</a:t>
+            </a:r>
+          </a:p>
+        </p:txBody>
+      </p:sp>
+      <p:sp>
+        <p:nvSpPr>
+          <p:cNvPr id="7" name="Rounded Rectangle 6"/>
+          <p:cNvSpPr/>
+          <p:nvPr/>
+        </p:nvSpPr>
+        <p:spPr>
+          <a:xfrm>
+            <a:off x="6172200" y="1691640"/>
+            <a:ext cx="5166360" cy="1371600"/>
+          </a:xfrm>
+          <a:prstGeom prst="roundRect">
+            <a:avLst>
+              <a:gd name="adj" fmla="val 6000"/>
+            </a:avLst>
+          </a:prstGeom>
+          <a:solidFill>
+            <a:srgbClr val="1E293B"/>
+          </a:solidFill>
+          <a:ln w="12700">
+            <a:solidFill>
+              <a:srgbClr val="334155"/>
+            </a:solidFill>
+          </a:ln>
+          <a:effectLst/>
+        </p:spPr>
+        <p:style>
+          <a:lnRef idx="1">
+            <a:schemeClr val="accent1"/>
+          </a:lnRef>
+          <a:fillRef idx="3">
+            <a:schemeClr val="accent1"/>
+          </a:fillRef>
+          <a:effectRef idx="2">
+            <a:schemeClr val="accent1"/>
+          </a:effectRef>
+          <a:fontRef idx="minor">
+            <a:schemeClr val="lt1"/>
+          </a:fontRef>
+        </p:style>
+        <p:txBody>
+          <a:bodyPr rtlCol="0" anchor="ctr"/>
+          <a:lstStyle/>
+          <a:p>
+            <a:pPr algn="ctr"/>
+          </a:p>
+        </p:txBody>
+      </p:sp>
+      <p:sp>
+        <p:nvSpPr>
+          <p:cNvPr id="8" name="TextBox 7"/>
+          <p:cNvSpPr txBox="1"/>
+          <p:nvPr/>
+        </p:nvSpPr>
+        <p:spPr>
+          <a:xfrm>
+            <a:off x="6446520" y="1874520"/>
+            <a:ext cx="4617720" cy="1005840"/>
+          </a:xfrm>
+          <a:prstGeom prst="rect">
+            <a:avLst/>
+          </a:prstGeom>
+          <a:noFill/>
+        </p:spPr>
+        <p:txBody>
+          <a:bodyPr wrap="square" anchor="t">
+            <a:spAutoFit/>
+          </a:bodyPr>
+          <a:lstStyle/>
+          <a:p>
+            <a:pPr>
+              <a:spcAft>
+                <a:spcPts val="400"/>
+              </a:spcAft>
+            </a:pPr>
+            <a:r>
+              <a:rPr sz="1700" b="1">
+                <a:solidFill>
+                  <a:srgbClr val="818CF8"/>
+                </a:solidFill>
+                <a:latin typeface="Segoe UI"/>
+              </a:rPr>
+              <a:t>AWS App Runner / ECS Fargate   </a:t>
+            </a:r>
+            <a:r>
+              <a:rPr sz="1400" i="1">
+                <a:solidFill>
+                  <a:srgbClr val="94A3B8"/>
+                </a:solidFill>
+                <a:latin typeface="Segoe UI"/>
+              </a:rPr>
+              <a:t>· Host the FastAPI app</a:t>
+            </a:r>
+          </a:p>
+          <a:p>
+            <a:pPr algn="l">
+              <a:spcAft>
+                <a:spcPts val="0"/>
+              </a:spcAft>
+            </a:pPr>
+            <a:r>
+              <a:rPr sz="1300" b="0">
+                <a:solidFill>
+                  <a:srgbClr val="E2E8F0"/>
+                </a:solidFill>
+                <a:latin typeface="Segoe UI"/>
+              </a:rPr>
+              <a:t>Run the existing web app as a container with autoscaling and HTTPS.</a:t>
+            </a:r>
+          </a:p>
+        </p:txBody>
+      </p:sp>
+      <p:sp>
+        <p:nvSpPr>
+          <p:cNvPr id="9" name="Rounded Rectangle 8"/>
+          <p:cNvSpPr/>
+          <p:nvPr/>
+        </p:nvSpPr>
+        <p:spPr>
+          <a:xfrm>
+            <a:off x="822960" y="3227832"/>
+            <a:ext cx="5166360" cy="1371600"/>
+          </a:xfrm>
+          <a:prstGeom prst="roundRect">
+            <a:avLst>
+              <a:gd name="adj" fmla="val 6000"/>
+            </a:avLst>
+          </a:prstGeom>
+          <a:solidFill>
+            <a:srgbClr val="1E293B"/>
+          </a:solidFill>
+          <a:ln w="12700">
+            <a:solidFill>
+              <a:srgbClr val="334155"/>
+            </a:solidFill>
+          </a:ln>
+          <a:effectLst/>
+        </p:spPr>
+        <p:style>
+          <a:lnRef idx="1">
+            <a:schemeClr val="accent1"/>
+          </a:lnRef>
+          <a:fillRef idx="3">
+            <a:schemeClr val="accent1"/>
+          </a:fillRef>
+          <a:effectRef idx="2">
+            <a:schemeClr val="accent1"/>
+          </a:effectRef>
+          <a:fontRef idx="minor">
+            <a:schemeClr val="lt1"/>
+          </a:fontRef>
+        </p:style>
+        <p:txBody>
+          <a:bodyPr rtlCol="0" anchor="ctr"/>
+          <a:lstStyle/>
+          <a:p>
+            <a:pPr algn="ctr"/>
+          </a:p>
+        </p:txBody>
+      </p:sp>
+      <p:sp>
+        <p:nvSpPr>
+          <p:cNvPr id="10" name="TextBox 9"/>
+          <p:cNvSpPr txBox="1"/>
+          <p:nvPr/>
+        </p:nvSpPr>
+        <p:spPr>
+          <a:xfrm>
+            <a:off x="1097280" y="3410712"/>
+            <a:ext cx="4617720" cy="1005840"/>
+          </a:xfrm>
+          <a:prstGeom prst="rect">
+            <a:avLst/>
+          </a:prstGeom>
+          <a:noFill/>
+        </p:spPr>
+        <p:txBody>
+          <a:bodyPr wrap="square" anchor="t">
+            <a:spAutoFit/>
+          </a:bodyPr>
+          <a:lstStyle/>
+          <a:p>
+            <a:pPr>
+              <a:spcAft>
+                <a:spcPts val="400"/>
+              </a:spcAft>
+            </a:pPr>
+            <a:r>
+              <a:rPr sz="1700" b="1">
+                <a:solidFill>
+                  <a:srgbClr val="818CF8"/>
+                </a:solidFill>
+                <a:latin typeface="Segoe UI"/>
+              </a:rPr>
+              <a:t>Amazon S3   </a:t>
+            </a:r>
+            <a:r>
+              <a:rPr sz="1400" i="1">
+                <a:solidFill>
+                  <a:srgbClr val="94A3B8"/>
+                </a:solidFill>
+                <a:latin typeface="Segoe UI"/>
+              </a:rPr>
+              <a:t>· Store generated PDFs</a:t>
+            </a:r>
+          </a:p>
+          <a:p>
+            <a:pPr algn="l">
+              <a:spcAft>
+                <a:spcPts val="0"/>
+              </a:spcAft>
+            </a:pPr>
+            <a:r>
+              <a:rPr sz="1300" b="0">
+                <a:solidFill>
+                  <a:srgbClr val="E2E8F0"/>
+                </a:solidFill>
+                <a:latin typeface="Segoe UI"/>
+              </a:rPr>
+              <a:t>Persist submission-ready documents instead of holding them in memory.</a:t>
+            </a:r>
+          </a:p>
+        </p:txBody>
+      </p:sp>
+      <p:sp>
+        <p:nvSpPr>
+          <p:cNvPr id="11" name="Rounded Rectangle 10"/>
+          <p:cNvSpPr/>
+          <p:nvPr/>
+        </p:nvSpPr>
+        <p:spPr>
+          <a:xfrm>
+            <a:off x="6172200" y="3227832"/>
+            <a:ext cx="5166360" cy="1371600"/>
+          </a:xfrm>
+          <a:prstGeom prst="roundRect">
+            <a:avLst>
+              <a:gd name="adj" fmla="val 6000"/>
+            </a:avLst>
+          </a:prstGeom>
+          <a:solidFill>
+            <a:srgbClr val="1E293B"/>
+          </a:solidFill>
+          <a:ln w="12700">
+            <a:solidFill>
+              <a:srgbClr val="334155"/>
+            </a:solidFill>
+          </a:ln>
+          <a:effectLst/>
+        </p:spPr>
+        <p:style>
+          <a:lnRef idx="1">
+            <a:schemeClr val="accent1"/>
+          </a:lnRef>
+          <a:fillRef idx="3">
+            <a:schemeClr val="accent1"/>
+          </a:fillRef>
+          <a:effectRef idx="2">
+            <a:schemeClr val="accent1"/>
+          </a:effectRef>
+          <a:fontRef idx="minor">
+            <a:schemeClr val="lt1"/>
+          </a:fontRef>
+        </p:style>
+        <p:txBody>
+          <a:bodyPr rtlCol="0" anchor="ctr"/>
+          <a:lstStyle/>
+          <a:p>
+            <a:pPr algn="ctr"/>
+          </a:p>
+        </p:txBody>
+      </p:sp>
+      <p:sp>
+        <p:nvSpPr>
+          <p:cNvPr id="12" name="TextBox 11"/>
+          <p:cNvSpPr txBox="1"/>
+          <p:nvPr/>
+        </p:nvSpPr>
+        <p:spPr>
+          <a:xfrm>
+            <a:off x="6446520" y="3410712"/>
+            <a:ext cx="4617720" cy="1005840"/>
+          </a:xfrm>
+          <a:prstGeom prst="rect">
+            <a:avLst/>
+          </a:prstGeom>
+          <a:noFill/>
+        </p:spPr>
+        <p:txBody>
+          <a:bodyPr wrap="square" anchor="t">
+            <a:spAutoFit/>
+          </a:bodyPr>
+          <a:lstStyle/>
+          <a:p>
+            <a:pPr>
+              <a:spcAft>
+                <a:spcPts val="400"/>
+              </a:spcAft>
+            </a:pPr>
+            <a:r>
+              <a:rPr sz="1700" b="1">
+                <a:solidFill>
+                  <a:srgbClr val="818CF8"/>
+                </a:solidFill>
+                <a:latin typeface="Segoe UI"/>
+              </a:rPr>
+              <a:t>Amazon DynamoDB / ElastiCache   </a:t>
+            </a:r>
+            <a:r>
+              <a:rPr sz="1400" i="1">
+                <a:solidFill>
+                  <a:srgbClr val="94A3B8"/>
+                </a:solidFill>
+                <a:latin typeface="Segoe UI"/>
+              </a:rPr>
+              <a:t>· Session + workflow state</a:t>
+            </a:r>
+          </a:p>
+          <a:p>
+            <a:pPr algn="l">
+              <a:spcAft>
+                <a:spcPts val="0"/>
+              </a:spcAft>
+            </a:pPr>
+            <a:r>
+              <a:rPr sz="1300" b="0">
+                <a:solidFill>
+                  <a:srgbClr val="E2E8F0"/>
+                </a:solidFill>
+                <a:latin typeface="Segoe UI"/>
+              </a:rPr>
+              <a:t>Replace the in-memory session store so conversations survive restarts and scale out.</a:t>
+            </a:r>
+          </a:p>
+        </p:txBody>
+      </p:sp>
+      <p:sp>
+        <p:nvSpPr>
+          <p:cNvPr id="13" name="Rounded Rectangle 12"/>
+          <p:cNvSpPr/>
+          <p:nvPr/>
+        </p:nvSpPr>
+        <p:spPr>
+          <a:xfrm>
+            <a:off x="822960" y="4764024"/>
+            <a:ext cx="5166360" cy="1371600"/>
+          </a:xfrm>
+          <a:prstGeom prst="roundRect">
+            <a:avLst>
+              <a:gd name="adj" fmla="val 6000"/>
+            </a:avLst>
+          </a:prstGeom>
+          <a:solidFill>
+            <a:srgbClr val="1E293B"/>
+          </a:solidFill>
+          <a:ln w="12700">
+            <a:solidFill>
+              <a:srgbClr val="334155"/>
+            </a:solidFill>
+          </a:ln>
+          <a:effectLst/>
+        </p:spPr>
+        <p:style>
+          <a:lnRef idx="1">
+            <a:schemeClr val="accent1"/>
+          </a:lnRef>
+          <a:fillRef idx="3">
+            <a:schemeClr val="accent1"/>
+          </a:fillRef>
+          <a:effectRef idx="2">
+            <a:schemeClr val="accent1"/>
+          </a:effectRef>
+          <a:fontRef idx="minor">
+            <a:schemeClr val="lt1"/>
+          </a:fontRef>
+        </p:style>
+        <p:txBody>
+          <a:bodyPr rtlCol="0" anchor="ctr"/>
+          <a:lstStyle/>
+          <a:p>
+            <a:pPr algn="ctr"/>
+          </a:p>
+        </p:txBody>
+      </p:sp>
+      <p:sp>
+        <p:nvSpPr>
+          <p:cNvPr id="14" name="TextBox 13"/>
+          <p:cNvSpPr txBox="1"/>
+          <p:nvPr/>
+        </p:nvSpPr>
+        <p:spPr>
+          <a:xfrm>
+            <a:off x="1097280" y="4946904"/>
+            <a:ext cx="4617720" cy="1005840"/>
+          </a:xfrm>
+          <a:prstGeom prst="rect">
+            <a:avLst/>
+          </a:prstGeom>
+          <a:noFill/>
+        </p:spPr>
+        <p:txBody>
+          <a:bodyPr wrap="square" anchor="t">
+            <a:spAutoFit/>
+          </a:bodyPr>
+          <a:lstStyle/>
+          <a:p>
+            <a:pPr>
+              <a:spcAft>
+                <a:spcPts val="400"/>
+              </a:spcAft>
+            </a:pPr>
+            <a:r>
+              <a:rPr sz="1700" b="1">
+                <a:solidFill>
+                  <a:srgbClr val="818CF8"/>
+                </a:solidFill>
+                <a:latin typeface="Segoe UI"/>
+              </a:rPr>
+              <a:t>Amazon Cognito   </a:t>
+            </a:r>
+            <a:r>
+              <a:rPr sz="1400" i="1">
+                <a:solidFill>
+                  <a:srgbClr val="94A3B8"/>
+                </a:solidFill>
+                <a:latin typeface="Segoe UI"/>
+              </a:rPr>
+              <a:t>· Student authentication</a:t>
+            </a:r>
+          </a:p>
+          <a:p>
+            <a:pPr algn="l">
+              <a:spcAft>
+                <a:spcPts val="0"/>
+              </a:spcAft>
+            </a:pPr>
+            <a:r>
+              <a:rPr sz="1300" b="0">
+                <a:solidFill>
+                  <a:srgbClr val="E2E8F0"/>
+                </a:solidFill>
+                <a:latin typeface="Segoe UI"/>
+              </a:rPr>
+              <a:t>Campus SSO / login so each submission is tied to a verified student.</a:t>
+            </a:r>
+          </a:p>
+        </p:txBody>
+      </p:sp>
+      <p:sp>
+        <p:nvSpPr>
+          <p:cNvPr id="15" name="Rounded Rectangle 14"/>
+          <p:cNvSpPr/>
+          <p:nvPr/>
+        </p:nvSpPr>
+        <p:spPr>
+          <a:xfrm>
+            <a:off x="6172200" y="4764024"/>
+            <a:ext cx="5166360" cy="1371600"/>
+          </a:xfrm>
+          <a:prstGeom prst="roundRect">
+            <a:avLst>
+              <a:gd name="adj" fmla="val 6000"/>
+            </a:avLst>
+          </a:prstGeom>
+          <a:solidFill>
+            <a:srgbClr val="1E293B"/>
+          </a:solidFill>
+          <a:ln w="12700">
+            <a:solidFill>
+              <a:srgbClr val="334155"/>
+            </a:solidFill>
+          </a:ln>
+          <a:effectLst/>
+        </p:spPr>
+        <p:style>
+          <a:lnRef idx="1">
+            <a:schemeClr val="accent1"/>
+          </a:lnRef>
+          <a:fillRef idx="3">
+            <a:schemeClr val="accent1"/>
+          </a:fillRef>
+          <a:effectRef idx="2">
+            <a:schemeClr val="accent1"/>
+          </a:effectRef>
+          <a:fontRef idx="minor">
+            <a:schemeClr val="lt1"/>
+          </a:fontRef>
+        </p:style>
+        <p:txBody>
+          <a:bodyPr rtlCol="0" anchor="ctr"/>
+          <a:lstStyle/>
+          <a:p>
+            <a:pPr algn="ctr"/>
+          </a:p>
+        </p:txBody>
+      </p:sp>
+      <p:sp>
+        <p:nvSpPr>
+          <p:cNvPr id="16" name="TextBox 15"/>
+          <p:cNvSpPr txBox="1"/>
+          <p:nvPr/>
+        </p:nvSpPr>
+        <p:spPr>
+          <a:xfrm>
+            <a:off x="6446520" y="4946904"/>
+            <a:ext cx="4617720" cy="1005840"/>
+          </a:xfrm>
+          <a:prstGeom prst="rect">
+            <a:avLst/>
+          </a:prstGeom>
+          <a:noFill/>
+        </p:spPr>
+        <p:txBody>
+          <a:bodyPr wrap="square" anchor="t">
+            <a:spAutoFit/>
+          </a:bodyPr>
+          <a:lstStyle/>
+          <a:p>
+            <a:pPr>
+              <a:spcAft>
+                <a:spcPts val="400"/>
+              </a:spcAft>
+            </a:pPr>
+            <a:r>
+              <a:rPr sz="1700" b="1">
+                <a:solidFill>
+                  <a:srgbClr val="818CF8"/>
+                </a:solidFill>
+                <a:latin typeface="Segoe UI"/>
+              </a:rPr>
+              <a:t>Amazon API Gateway + CloudWatch   </a:t>
+            </a:r>
+            <a:r>
+              <a:rPr sz="1400" i="1">
+                <a:solidFill>
+                  <a:srgbClr val="94A3B8"/>
+                </a:solidFill>
+                <a:latin typeface="Segoe UI"/>
+              </a:rPr>
+              <a:t>· Routing &amp; observability</a:t>
+            </a:r>
+          </a:p>
+          <a:p>
+            <a:pPr algn="l">
+              <a:spcAft>
+                <a:spcPts val="0"/>
+              </a:spcAft>
+            </a:pPr>
+            <a:r>
+              <a:rPr sz="1300" b="0">
+                <a:solidFill>
+                  <a:srgbClr val="E2E8F0"/>
+                </a:solidFill>
+                <a:latin typeface="Segoe UI"/>
+              </a:rPr>
+              <a:t>Managed entry point for the chat API with logging, metrics, and alarms.</a:t>
+            </a:r>
+          </a:p>
+        </p:txBody>
+      </p:sp>
+      <p:sp>
+        <p:nvSpPr>
+          <p:cNvPr id="17" name="TextBox 16"/>
+          <p:cNvSpPr txBox="1"/>
+          <p:nvPr/>
+        </p:nvSpPr>
+        <p:spPr>
+          <a:xfrm>
+            <a:off x="822960" y="6355080"/>
+            <a:ext cx="10515600" cy="411480"/>
+          </a:xfrm>
+          <a:prstGeom prst="rect">
+            <a:avLst/>
+          </a:prstGeom>
+          <a:noFill/>
+        </p:spPr>
+        <p:txBody>
+          <a:bodyPr wrap="square" anchor="t">
+            <a:spAutoFit/>
+          </a:bodyPr>
+          <a:lstStyle/>
+          <a:p>
+            <a:pPr algn="ctr">
+              <a:spcAft>
+                <a:spcPts val="1000"/>
+              </a:spcAft>
+            </a:pPr>
+            <a:r>
+              <a:rPr sz="1200" b="0">
+                <a:solidFill>
+                  <a:srgbClr val="94A3B8"/>
+                </a:solidFill>
+                <a:latin typeface="Segoe UI"/>
+              </a:rPr>
+              <a:t>Note: a proposed deployment architecture — the current prototype runs locally and is cloud-ready by design.</a:t>
+            </a:r>
+          </a:p>
+        </p:txBody>
+      </p:sp>
+    </p:spTree>
+  </p:cSld>
+  <p:clrMapOvr>
+    <a:masterClrMapping/>
+  </p:clrMapOvr>
+</p:sld>
+</file>
+
+<file path=ppt/slides/slide7.xml><?xml version="1.0" encoding="utf-8"?>
 <p:sld xmlns:a="http://schemas.openxmlformats.org/drawingml/2006/main" xmlns:p="http://schemas.openxmlformats.org/presentationml/2006/main" xmlns:r="http://schemas.openxmlformats.org/officeDocument/2006/relationships">
   <p:cSld>
     <p:spTree>

</xml_diff>